<commit_message>
fixed bullet formatting bug
</commit_message>
<xml_diff>
--- a/test.pptx
+++ b/test.pptx
@@ -12,6 +12,12 @@
     <p:sldId id="260" r:id="rId11"/>
     <p:sldId id="261" r:id="rId12"/>
     <p:sldId id="262" r:id="rId13"/>
+    <p:sldId id="263" r:id="rId14"/>
+    <p:sldId id="264" r:id="rId15"/>
+    <p:sldId id="265" r:id="rId16"/>
+    <p:sldId id="266" r:id="rId17"/>
+    <p:sldId id="267" r:id="rId18"/>
+    <p:sldId id="268" r:id="rId19"/>
   </p:sldIdLst>
   <p:sldSz cx="9144000" cy="6858000" type="screen4x3"/>
   <p:notesSz cx="6858000" cy="9144000"/>
@@ -3101,6 +3107,66 @@
             <a:spLocks noGrp="1"/>
           </p:cNvSpPr>
           <p:nvPr>
+            <p:ph type="ctrTitle"/>
+          </p:nvPr>
+        </p:nvSpPr>
+        <p:spPr/>
+        <p:txBody>
+          <a:bodyPr/>
+          <a:lstStyle/>
+          <a:p>
+            <a:r>
+              <a:t>Artificial Intelligence: Shaping the Future</a:t>
+            </a:r>
+          </a:p>
+        </p:txBody>
+      </p:sp>
+      <p:sp>
+        <p:nvSpPr>
+          <p:cNvPr id="3" name="Subtitle 2"/>
+          <p:cNvSpPr>
+            <a:spLocks noGrp="1"/>
+          </p:cNvSpPr>
+          <p:nvPr>
+            <p:ph type="subTitle" idx="1"/>
+          </p:nvPr>
+        </p:nvSpPr>
+        <p:spPr/>
+        <p:txBody>
+          <a:bodyPr/>
+          <a:lstStyle/>
+          <a:p>
+            <a:r>
+              <a:t>Exploring the revolutionary technology that's transforming our world</a:t>
+            </a:r>
+          </a:p>
+        </p:txBody>
+      </p:sp>
+    </p:spTree>
+  </p:cSld>
+  <p:clrMapOvr>
+    <a:masterClrMapping/>
+  </p:clrMapOvr>
+</p:sld>
+</file>
+
+<file path=ppt/slides/slide10.xml><?xml version="1.0" encoding="utf-8"?>
+<p:sld xmlns:a="http://schemas.openxmlformats.org/drawingml/2006/main" xmlns:p="http://schemas.openxmlformats.org/presentationml/2006/main" xmlns:r="http://schemas.openxmlformats.org/officeDocument/2006/relationships">
+  <p:cSld>
+    <p:spTree>
+      <p:nvGrpSpPr>
+        <p:cNvPr id="1" name=""/>
+        <p:cNvGrpSpPr/>
+        <p:nvPr/>
+      </p:nvGrpSpPr>
+      <p:grpSpPr/>
+      <p:sp>
+        <p:nvSpPr>
+          <p:cNvPr id="2" name="Title 1"/>
+          <p:cNvSpPr>
+            <a:spLocks noGrp="1"/>
+          </p:cNvSpPr>
+          <p:nvPr>
             <p:ph type="title"/>
           </p:nvPr>
         </p:nvSpPr>
@@ -3110,7 +3176,7 @@
           <a:lstStyle/>
           <a:p>
             <a:r>
-              <a:t>Introduction to Artificial Intelligence</a:t>
+              <a:t>AI Ethics and Governance</a:t>
             </a:r>
           </a:p>
         </p:txBody>
@@ -3131,8 +3197,302 @@
           <a:lstStyle/>
           <a:p/>
           <a:p>
-            <a:r>
-              <a:t>Artificial Intelligence (AI) refers to the development of computer systems that can perform tasks that would typically require human intelligence, such as learning, problem-solving, and decision-making.</a:t>
+            <a:pPr lvl="1"/>
+            <a:r>
+              <a:t>Need for transparent and accountable AI systems</a:t>
+            </a:r>
+          </a:p>
+          <a:p>
+            <a:pPr lvl="1"/>
+            <a:r>
+              <a:t>Ensuring fairness and preventing discrimination</a:t>
+            </a:r>
+          </a:p>
+          <a:p>
+            <a:pPr lvl="1"/>
+            <a:r>
+              <a:t>Protecting individual privacy rights</a:t>
+            </a:r>
+          </a:p>
+          <a:p>
+            <a:pPr lvl="1"/>
+            <a:r>
+              <a:t>Establishing regulatory frameworks</a:t>
+            </a:r>
+          </a:p>
+          <a:p>
+            <a:pPr lvl="1"/>
+            <a:r>
+              <a:t>Promoting responsible AI development</a:t>
+            </a:r>
+          </a:p>
+          <a:p>
+            <a:pPr lvl="1"/>
+            <a:r>
+              <a:t>Balancing innovation with safety</a:t>
+            </a:r>
+          </a:p>
+          <a:p>
+            <a:pPr lvl="1"/>
+            <a:r>
+              <a:t>International cooperation on AI standards</a:t>
+            </a:r>
+          </a:p>
+        </p:txBody>
+      </p:sp>
+    </p:spTree>
+  </p:cSld>
+  <p:clrMapOvr>
+    <a:masterClrMapping/>
+  </p:clrMapOvr>
+</p:sld>
+</file>
+
+<file path=ppt/slides/slide11.xml><?xml version="1.0" encoding="utf-8"?>
+<p:sld xmlns:a="http://schemas.openxmlformats.org/drawingml/2006/main" xmlns:p="http://schemas.openxmlformats.org/presentationml/2006/main" xmlns:r="http://schemas.openxmlformats.org/officeDocument/2006/relationships">
+  <p:cSld>
+    <p:spTree>
+      <p:nvGrpSpPr>
+        <p:cNvPr id="1" name=""/>
+        <p:cNvGrpSpPr/>
+        <p:nvPr/>
+      </p:nvGrpSpPr>
+      <p:grpSpPr/>
+      <p:sp>
+        <p:nvSpPr>
+          <p:cNvPr id="2" name="Title 1"/>
+          <p:cNvSpPr>
+            <a:spLocks noGrp="1"/>
+          </p:cNvSpPr>
+          <p:nvPr>
+            <p:ph type="title"/>
+          </p:nvPr>
+        </p:nvSpPr>
+        <p:spPr/>
+        <p:txBody>
+          <a:bodyPr/>
+          <a:lstStyle/>
+          <a:p>
+            <a:r>
+              <a:t>The Future of AI</a:t>
+            </a:r>
+          </a:p>
+        </p:txBody>
+      </p:sp>
+      <p:sp>
+        <p:nvSpPr>
+          <p:cNvPr id="3" name="Content Placeholder 2"/>
+          <p:cNvSpPr>
+            <a:spLocks noGrp="1"/>
+          </p:cNvSpPr>
+          <p:nvPr>
+            <p:ph idx="1"/>
+          </p:nvPr>
+        </p:nvSpPr>
+        <p:spPr/>
+        <p:txBody>
+          <a:bodyPr/>
+          <a:lstStyle/>
+          <a:p/>
+          <a:p>
+            <a:pPr lvl="1"/>
+            <a:r>
+              <a:t>Continued advancement in machine learning capabilities</a:t>
+            </a:r>
+          </a:p>
+          <a:p>
+            <a:pPr lvl="1"/>
+            <a:r>
+              <a:t>Integration with Internet of Things (IoT)</a:t>
+            </a:r>
+          </a:p>
+          <a:p>
+            <a:pPr lvl="1"/>
+            <a:r>
+              <a:t>Enhanced human-AI collaboration</a:t>
+            </a:r>
+          </a:p>
+          <a:p>
+            <a:pPr lvl="1"/>
+            <a:r>
+              <a:t>Breakthrough in general AI research</a:t>
+            </a:r>
+          </a:p>
+          <a:p>
+            <a:pPr lvl="1"/>
+            <a:r>
+              <a:t>Quantum computing revolutionizing AI</a:t>
+            </a:r>
+          </a:p>
+          <a:p>
+            <a:pPr lvl="1"/>
+            <a:r>
+              <a:t>AI in space exploration and scientific discovery</a:t>
+            </a:r>
+          </a:p>
+          <a:p>
+            <a:pPr lvl="1"/>
+            <a:r>
+              <a:t>Potential for solving global challenges</a:t>
+            </a:r>
+          </a:p>
+        </p:txBody>
+      </p:sp>
+    </p:spTree>
+  </p:cSld>
+  <p:clrMapOvr>
+    <a:masterClrMapping/>
+  </p:clrMapOvr>
+</p:sld>
+</file>
+
+<file path=ppt/slides/slide12.xml><?xml version="1.0" encoding="utf-8"?>
+<p:sld xmlns:a="http://schemas.openxmlformats.org/drawingml/2006/main" xmlns:p="http://schemas.openxmlformats.org/presentationml/2006/main" xmlns:r="http://schemas.openxmlformats.org/officeDocument/2006/relationships">
+  <p:cSld>
+    <p:spTree>
+      <p:nvGrpSpPr>
+        <p:cNvPr id="1" name=""/>
+        <p:cNvGrpSpPr/>
+        <p:nvPr/>
+      </p:nvGrpSpPr>
+      <p:grpSpPr/>
+      <p:sp>
+        <p:nvSpPr>
+          <p:cNvPr id="2" name="Title 1"/>
+          <p:cNvSpPr>
+            <a:spLocks noGrp="1"/>
+          </p:cNvSpPr>
+          <p:nvPr>
+            <p:ph type="title"/>
+          </p:nvPr>
+        </p:nvSpPr>
+        <p:spPr/>
+        <p:txBody>
+          <a:bodyPr/>
+          <a:lstStyle/>
+          <a:p>
+            <a:r>
+              <a:t>Preparing for an AI Future</a:t>
+            </a:r>
+          </a:p>
+        </p:txBody>
+      </p:sp>
+      <p:sp>
+        <p:nvSpPr>
+          <p:cNvPr id="3" name="Content Placeholder 2"/>
+          <p:cNvSpPr>
+            <a:spLocks noGrp="1"/>
+          </p:cNvSpPr>
+          <p:nvPr>
+            <p:ph idx="1"/>
+          </p:nvPr>
+        </p:nvSpPr>
+        <p:spPr/>
+        <p:txBody>
+          <a:bodyPr/>
+          <a:lstStyle/>
+          <a:p/>
+          <a:p>
+            <a:pPr lvl="1"/>
+            <a:r>
+              <a:t>Developing AI literacy and digital skills</a:t>
+            </a:r>
+          </a:p>
+          <a:p>
+            <a:pPr lvl="1"/>
+            <a:r>
+              <a:t>Emphasizing human creativity and emotional intelligence</a:t>
+            </a:r>
+          </a:p>
+          <a:p>
+            <a:pPr lvl="1"/>
+            <a:r>
+              <a:t>Creating adaptive education systems</a:t>
+            </a:r>
+          </a:p>
+          <a:p>
+            <a:pPr lvl="1"/>
+            <a:r>
+              <a:t>Establishing ethical guidelines</a:t>
+            </a:r>
+          </a:p>
+          <a:p>
+            <a:pPr lvl="1"/>
+            <a:r>
+              <a:t>Investing in AI research and development</a:t>
+            </a:r>
+          </a:p>
+          <a:p>
+            <a:pPr lvl="1"/>
+            <a:r>
+              <a:t>Building inclusive AI for everyone</a:t>
+            </a:r>
+          </a:p>
+          <a:p>
+            <a:pPr lvl="1"/>
+            <a:r>
+              <a:t>Fostering human-AI partnership</a:t>
+            </a:r>
+          </a:p>
+        </p:txBody>
+      </p:sp>
+    </p:spTree>
+  </p:cSld>
+  <p:clrMapOvr>
+    <a:masterClrMapping/>
+  </p:clrMapOvr>
+</p:sld>
+</file>
+
+<file path=ppt/slides/slide13.xml><?xml version="1.0" encoding="utf-8"?>
+<p:sld xmlns:a="http://schemas.openxmlformats.org/drawingml/2006/main" xmlns:p="http://schemas.openxmlformats.org/presentationml/2006/main" xmlns:r="http://schemas.openxmlformats.org/officeDocument/2006/relationships">
+  <p:cSld>
+    <p:spTree>
+      <p:nvGrpSpPr>
+        <p:cNvPr id="1" name=""/>
+        <p:cNvGrpSpPr/>
+        <p:nvPr/>
+      </p:nvGrpSpPr>
+      <p:grpSpPr/>
+      <p:sp>
+        <p:nvSpPr>
+          <p:cNvPr id="2" name="Title 1"/>
+          <p:cNvSpPr>
+            <a:spLocks noGrp="1"/>
+          </p:cNvSpPr>
+          <p:nvPr>
+            <p:ph type="title"/>
+          </p:nvPr>
+        </p:nvSpPr>
+        <p:spPr/>
+        <p:txBody>
+          <a:bodyPr/>
+          <a:lstStyle/>
+          <a:p>
+            <a:r>
+              <a:t>Conclusion</a:t>
+            </a:r>
+          </a:p>
+        </p:txBody>
+      </p:sp>
+      <p:sp>
+        <p:nvSpPr>
+          <p:cNvPr id="3" name="Content Placeholder 2"/>
+          <p:cNvSpPr>
+            <a:spLocks noGrp="1"/>
+          </p:cNvSpPr>
+          <p:nvPr>
+            <p:ph idx="1"/>
+          </p:nvPr>
+        </p:nvSpPr>
+        <p:spPr/>
+        <p:txBody>
+          <a:bodyPr/>
+          <a:lstStyle/>
+          <a:p/>
+          <a:p>
+            <a:r>
+              <a:t>Artificial Intelligence represents one of the most transformative technologies of our time. While it presents incredible opportunities for advancement across all sectors of society, it also requires careful consideration of ethical implications and responsible development. By understanding AI's capabilities and limitations, we can harness its power to create a better future for humanity.</a:t>
             </a:r>
           </a:p>
         </p:txBody>
@@ -3171,7 +3531,7 @@
           <a:lstStyle/>
           <a:p>
             <a:r>
-              <a:t>History of AI</a:t>
+              <a:t>What is Artificial Intelligence?</a:t>
             </a:r>
           </a:p>
         </p:txBody>
@@ -3183,7 +3543,7 @@
             <a:spLocks noGrp="1"/>
           </p:cNvSpPr>
           <p:nvPr>
-            <p:ph idx="1" sz="half"/>
+            <p:ph idx="1"/>
           </p:nvPr>
         </p:nvSpPr>
         <p:spPr/>
@@ -3192,30 +3552,27 @@
           <a:lstStyle/>
           <a:p/>
           <a:p>
-            <a:r>
-              <a:t>The term AI was first coined in 1956 by John McCarthy. Since then, AI has undergone significant developments, from rule-based systems to machine learning and deep learning.</a:t>
-            </a:r>
-          </a:p>
-        </p:txBody>
-      </p:sp>
-      <p:sp>
-        <p:nvSpPr>
-          <p:cNvPr id="4" name="Content Placeholder 3"/>
-          <p:cNvSpPr>
-            <a:spLocks noGrp="1"/>
-          </p:cNvSpPr>
-          <p:nvPr>
-            <p:ph idx="2" sz="half"/>
-          </p:nvPr>
-        </p:nvSpPr>
-        <p:spPr/>
-        <p:txBody>
-          <a:bodyPr/>
-          <a:lstStyle/>
-          <a:p/>
-          <a:p>
-            <a:r>
-              <a:t>AI has been influenced by various fields, including mathematics, computer science, and cognitive psychology.</a:t>
+            <a:pPr lvl="1"/>
+            <a:r>
+              <a:t>Computer systems that can perform tasks requiring human intelligence</a:t>
+            </a:r>
+          </a:p>
+          <a:p>
+            <a:pPr lvl="1"/>
+            <a:r>
+              <a:t>Includes learning, reasoning, problem-solving, and decision-making</a:t>
+            </a:r>
+          </a:p>
+          <a:p>
+            <a:pPr lvl="1"/>
+            <a:r>
+              <a:t>Ranges from narrow AI (specific tasks) to general AI (human-like intelligence)</a:t>
+            </a:r>
+          </a:p>
+          <a:p>
+            <a:pPr lvl="1"/>
+            <a:r>
+              <a:t>Combines computer science, mathematics, psychology, and neuroscience</a:t>
             </a:r>
           </a:p>
         </p:txBody>
@@ -3254,40 +3611,19 @@
           <a:lstStyle/>
           <a:p>
             <a:r>
-              <a:t>Types of AI</a:t>
-            </a:r>
-          </a:p>
-        </p:txBody>
-      </p:sp>
-      <p:sp>
-        <p:nvSpPr>
-          <p:cNvPr id="3" name="Text Placeholder 2"/>
-          <p:cNvSpPr>
-            <a:spLocks noGrp="1"/>
-          </p:cNvSpPr>
-          <p:nvPr>
-            <p:ph type="body" idx="1"/>
-          </p:nvPr>
-        </p:nvSpPr>
-        <p:spPr/>
-        <p:txBody>
-          <a:bodyPr/>
-          <a:lstStyle/>
-          <a:p>
-            <a:r>
-              <a:t>Narrow or Weak AI</a:t>
-            </a:r>
-          </a:p>
-        </p:txBody>
-      </p:sp>
-      <p:sp>
-        <p:nvSpPr>
-          <p:cNvPr id="4" name="Content Placeholder 3"/>
-          <p:cNvSpPr>
-            <a:spLocks noGrp="1"/>
-          </p:cNvSpPr>
-          <p:nvPr>
-            <p:ph idx="2" sz="half"/>
+              <a:t>Brief History of AI</a:t>
+            </a:r>
+          </a:p>
+        </p:txBody>
+      </p:sp>
+      <p:sp>
+        <p:nvSpPr>
+          <p:cNvPr id="3" name="Content Placeholder 2"/>
+          <p:cNvSpPr>
+            <a:spLocks noGrp="1"/>
+          </p:cNvSpPr>
+          <p:nvPr>
+            <p:ph idx="1"/>
           </p:nvPr>
         </p:nvSpPr>
         <p:spPr/>
@@ -3298,59 +3634,37 @@
           <a:p>
             <a:pPr lvl="1"/>
             <a:r>
-              <a:t>Designed to perform a specific task</a:t>
-            </a:r>
-            <a:br/>
-            <a:r>
-              <a:t>Limited to a particular domain</a:t>
-            </a:r>
-          </a:p>
-        </p:txBody>
-      </p:sp>
-      <p:sp>
-        <p:nvSpPr>
-          <p:cNvPr id="5" name="Text Placeholder 4"/>
-          <p:cNvSpPr>
-            <a:spLocks noGrp="1"/>
-          </p:cNvSpPr>
-          <p:nvPr>
-            <p:ph type="body" idx="3" sz="quarter"/>
-          </p:nvPr>
-        </p:nvSpPr>
-        <p:spPr/>
-        <p:txBody>
-          <a:bodyPr/>
-          <a:lstStyle/>
-          <a:p>
-            <a:r>
-              <a:t>General or Strong AI</a:t>
-            </a:r>
-          </a:p>
-        </p:txBody>
-      </p:sp>
-      <p:sp>
-        <p:nvSpPr>
-          <p:cNvPr id="6" name="Content Placeholder 5"/>
-          <p:cNvSpPr>
-            <a:spLocks noGrp="1"/>
-          </p:cNvSpPr>
-          <p:nvPr>
-            <p:ph idx="4" sz="quarter"/>
-          </p:nvPr>
-        </p:nvSpPr>
-        <p:spPr/>
-        <p:txBody>
-          <a:bodyPr/>
-          <a:lstStyle/>
-          <a:p/>
-          <a:p>
-            <a:pPr lvl="1"/>
-            <a:r>
-              <a:t>Able to perform any intellectual task</a:t>
-            </a:r>
-            <a:br/>
-            <a:r>
-              <a:t>Still in the development stage</a:t>
+              <a:t>1950s: Alan Turing proposes the Turing Test</a:t>
+            </a:r>
+          </a:p>
+          <a:p>
+            <a:pPr lvl="1"/>
+            <a:r>
+              <a:t>1956: Term 'Artificial Intelligence' coined at Dartmouth Conference</a:t>
+            </a:r>
+          </a:p>
+          <a:p>
+            <a:pPr lvl="1"/>
+            <a:r>
+              <a:t>1997: Deep Blue defeats world chess champion</a:t>
+            </a:r>
+          </a:p>
+          <a:p>
+            <a:pPr lvl="1"/>
+            <a:r>
+              <a:t>2011: IBM Watson wins Jeopardy!</a:t>
+            </a:r>
+          </a:p>
+          <a:p>
+            <a:pPr lvl="1"/>
+            <a:r>
+              <a:t>2016: AlphaGo defeats Go world champion</a:t>
+            </a:r>
+          </a:p>
+          <a:p>
+            <a:pPr lvl="1"/>
+            <a:r>
+              <a:t>2022: ChatGPT launches, bringing AI to mainstream</a:t>
             </a:r>
           </a:p>
         </p:txBody>
@@ -3389,7 +3703,7 @@
           <a:lstStyle/>
           <a:p>
             <a:r>
-              <a:t>Applications of AI</a:t>
+              <a:t>Types of AI</a:t>
             </a:r>
           </a:p>
         </p:txBody>
@@ -3412,19 +3726,31 @@
           <a:p>
             <a:pPr lvl="1"/>
             <a:r>
-              <a:t>Virtual assistants</a:t>
-            </a:r>
-            <a:br/>
-            <a:r>
-              <a:t>Image recognition</a:t>
-            </a:r>
-            <a:br/>
-            <a:r>
-              <a:t>Natural language processing</a:t>
-            </a:r>
-            <a:br/>
-            <a:r>
-              <a:t>Predictive maintenance</a:t>
+              <a:t>Narrow AI: Designed for specific tasks (Siri, Netflix recommendations)</a:t>
+            </a:r>
+          </a:p>
+          <a:p>
+            <a:pPr lvl="1"/>
+            <a:r>
+              <a:t>General AI: Hypothetical AI with human-level intelligence across all domains</a:t>
+            </a:r>
+          </a:p>
+          <a:p>
+            <a:pPr lvl="1"/>
+            <a:r>
+              <a:t>Super AI: Theoretical AI surpassing human intelligence</a:t>
+            </a:r>
+          </a:p>
+          <a:p>
+            <a:pPr lvl="1"/>
+            <a:r>
+              <a:t>Machine Learning: Algorithms that improve through experience</a:t>
+            </a:r>
+          </a:p>
+          <a:p>
+            <a:pPr lvl="1"/>
+            <a:r>
+              <a:t>Deep Learning: Neural networks with multiple layers</a:t>
             </a:r>
           </a:p>
         </p:txBody>
@@ -3463,7 +3789,7 @@
           <a:lstStyle/>
           <a:p>
             <a:r>
-              <a:t>AI in Healthcare</a:t>
+              <a:t>How AI Works</a:t>
             </a:r>
           </a:p>
         </p:txBody>
@@ -3475,7 +3801,7 @@
             <a:spLocks noGrp="1"/>
           </p:cNvSpPr>
           <p:nvPr>
-            <p:ph idx="1" sz="half"/>
+            <p:ph idx="1"/>
           </p:nvPr>
         </p:nvSpPr>
         <p:spPr/>
@@ -3484,30 +3810,39 @@
           <a:lstStyle/>
           <a:p/>
           <a:p>
-            <a:r>
-              <a:t>AI is being used in healthcare to improve patient outcomes, enhance disease diagnosis, and personalize treatment plans.</a:t>
-            </a:r>
-          </a:p>
-        </p:txBody>
-      </p:sp>
-      <p:sp>
-        <p:nvSpPr>
-          <p:cNvPr id="4" name="Content Placeholder 3"/>
-          <p:cNvSpPr>
-            <a:spLocks noGrp="1"/>
-          </p:cNvSpPr>
-          <p:nvPr>
-            <p:ph idx="2" sz="half"/>
-          </p:nvPr>
-        </p:nvSpPr>
-        <p:spPr/>
-        <p:txBody>
-          <a:bodyPr/>
-          <a:lstStyle/>
-          <a:p/>
-          <a:p>
-            <a:r>
-              <a:t>AI-powered chatbots are also being used to provide patients with personalized support and guidance.</a:t>
+            <a:pPr lvl="1"/>
+            <a:r>
+              <a:t>Data Collection: Gathering relevant information</a:t>
+            </a:r>
+          </a:p>
+          <a:p>
+            <a:pPr lvl="1"/>
+            <a:r>
+              <a:t>Training: Teaching algorithms using data patterns</a:t>
+            </a:r>
+          </a:p>
+          <a:p>
+            <a:pPr lvl="1"/>
+            <a:r>
+              <a:t>Neural Networks: Simulating human brain connections</a:t>
+            </a:r>
+          </a:p>
+          <a:p>
+            <a:pPr lvl="1"/>
+            <a:r>
+              <a:t>Natural Language Processing: Understanding human language</a:t>
+            </a:r>
+          </a:p>
+          <a:p>
+            <a:pPr lvl="1"/>
+            <a:r>
+              <a:t>Computer Vision: Interpreting visual information</a:t>
+            </a:r>
+          </a:p>
+          <a:p>
+            <a:pPr lvl="1"/>
+            <a:r>
+              <a:t>Reinforcement Learning: Learning through trial and error</a:t>
             </a:r>
           </a:p>
         </p:txBody>
@@ -3546,7 +3881,7 @@
           <a:lstStyle/>
           <a:p>
             <a:r>
-              <a:t>AI in Finance</a:t>
+              <a:t>AI vs Traditional Programming</a:t>
             </a:r>
           </a:p>
         </p:txBody>
@@ -3567,7 +3902,7 @@
           <a:lstStyle/>
           <a:p>
             <a:r>
-              <a:t>Risk Management</a:t>
+              <a:t>Traditional Programming</a:t>
             </a:r>
           </a:p>
         </p:txBody>
@@ -3590,15 +3925,31 @@
           <a:p>
             <a:pPr lvl="1"/>
             <a:r>
-              <a:t>Detect and prevent fraudulent activities</a:t>
-            </a:r>
-            <a:br/>
-            <a:r>
-              <a:t>Predict market trends</a:t>
-            </a:r>
-            <a:br/>
-            <a:r>
-              <a:t>Analyze customer behavior</a:t>
+              <a:t>Explicit rules defined by programmers</a:t>
+            </a:r>
+          </a:p>
+          <a:p>
+            <a:pPr lvl="1"/>
+            <a:r>
+              <a:t>Fixed logic and decision trees</a:t>
+            </a:r>
+          </a:p>
+          <a:p>
+            <a:pPr lvl="1"/>
+            <a:r>
+              <a:t>Limited adaptability</a:t>
+            </a:r>
+          </a:p>
+          <a:p>
+            <a:pPr lvl="1"/>
+            <a:r>
+              <a:t>Requires manual updates for changes</a:t>
+            </a:r>
+          </a:p>
+          <a:p>
+            <a:pPr lvl="1"/>
+            <a:r>
+              <a:t>Predictable outcomes based on code</a:t>
             </a:r>
           </a:p>
         </p:txBody>
@@ -3619,7 +3970,7 @@
           <a:lstStyle/>
           <a:p>
             <a:r>
-              <a:t>Investment Analysis</a:t>
+              <a:t>Artificial Intelligence</a:t>
             </a:r>
           </a:p>
         </p:txBody>
@@ -3642,15 +3993,31 @@
           <a:p>
             <a:pPr lvl="1"/>
             <a:r>
-              <a:t>Analyze large datasets</a:t>
-            </a:r>
-            <a:br/>
-            <a:r>
-              <a:t>Identify patterns</a:t>
-            </a:r>
-            <a:br/>
-            <a:r>
-              <a:t>Make investment recommendations</a:t>
+              <a:t>Learns patterns from data</a:t>
+            </a:r>
+          </a:p>
+          <a:p>
+            <a:pPr lvl="1"/>
+            <a:r>
+              <a:t>Adapts and improves over time</a:t>
+            </a:r>
+          </a:p>
+          <a:p>
+            <a:pPr lvl="1"/>
+            <a:r>
+              <a:t>Handles uncertainty and variation</a:t>
+            </a:r>
+          </a:p>
+          <a:p>
+            <a:pPr lvl="1"/>
+            <a:r>
+              <a:t>Autonomous decision-making</a:t>
+            </a:r>
+          </a:p>
+          <a:p>
+            <a:pPr lvl="1"/>
+            <a:r>
+              <a:t>Can discover unexpected solutions</a:t>
             </a:r>
           </a:p>
         </p:txBody>
@@ -3689,7 +4056,7 @@
           <a:lstStyle/>
           <a:p>
             <a:r>
-              <a:t>Conclusion</a:t>
+              <a:t>Real-World Applications</a:t>
             </a:r>
           </a:p>
         </p:txBody>
@@ -3710,8 +4077,235 @@
           <a:lstStyle/>
           <a:p/>
           <a:p>
-            <a:r>
-              <a:t>Artificial Intelligence has the potential to revolutionize various industries and aspects of our lives. As AI technology continues to evolve, we can expect to see significant advancements in the coming years.</a:t>
+            <a:pPr lvl="1"/>
+            <a:r>
+              <a:t>Healthcare: Disease diagnosis, drug discovery, personalized treatment</a:t>
+            </a:r>
+          </a:p>
+          <a:p>
+            <a:pPr lvl="1"/>
+            <a:r>
+              <a:t>Transportation: Self-driving cars, traffic optimization, route planning</a:t>
+            </a:r>
+          </a:p>
+          <a:p>
+            <a:pPr lvl="1"/>
+            <a:r>
+              <a:t>Finance: Fraud detection, algorithmic trading, credit scoring</a:t>
+            </a:r>
+          </a:p>
+          <a:p>
+            <a:pPr lvl="1"/>
+            <a:r>
+              <a:t>Education: Personalized learning, automated grading, tutoring systems</a:t>
+            </a:r>
+          </a:p>
+          <a:p>
+            <a:pPr lvl="1"/>
+            <a:r>
+              <a:t>Entertainment: Content recommendation, game AI, music composition</a:t>
+            </a:r>
+          </a:p>
+          <a:p>
+            <a:pPr lvl="1"/>
+            <a:r>
+              <a:t>Manufacturing: Quality control, predictive maintenance, robotics</a:t>
+            </a:r>
+          </a:p>
+        </p:txBody>
+      </p:sp>
+    </p:spTree>
+  </p:cSld>
+  <p:clrMapOvr>
+    <a:masterClrMapping/>
+  </p:clrMapOvr>
+</p:sld>
+</file>
+
+<file path=ppt/slides/slide8.xml><?xml version="1.0" encoding="utf-8"?>
+<p:sld xmlns:a="http://schemas.openxmlformats.org/drawingml/2006/main" xmlns:p="http://schemas.openxmlformats.org/presentationml/2006/main" xmlns:r="http://schemas.openxmlformats.org/officeDocument/2006/relationships">
+  <p:cSld>
+    <p:spTree>
+      <p:nvGrpSpPr>
+        <p:cNvPr id="1" name=""/>
+        <p:cNvGrpSpPr/>
+        <p:nvPr/>
+      </p:nvGrpSpPr>
+      <p:grpSpPr/>
+      <p:sp>
+        <p:nvSpPr>
+          <p:cNvPr id="2" name="Title 1"/>
+          <p:cNvSpPr>
+            <a:spLocks noGrp="1"/>
+          </p:cNvSpPr>
+          <p:nvPr>
+            <p:ph type="title"/>
+          </p:nvPr>
+        </p:nvSpPr>
+        <p:spPr/>
+        <p:txBody>
+          <a:bodyPr/>
+          <a:lstStyle/>
+          <a:p>
+            <a:r>
+              <a:t>Benefits of AI</a:t>
+            </a:r>
+          </a:p>
+        </p:txBody>
+      </p:sp>
+      <p:sp>
+        <p:nvSpPr>
+          <p:cNvPr id="3" name="Content Placeholder 2"/>
+          <p:cNvSpPr>
+            <a:spLocks noGrp="1"/>
+          </p:cNvSpPr>
+          <p:nvPr>
+            <p:ph idx="1"/>
+          </p:nvPr>
+        </p:nvSpPr>
+        <p:spPr/>
+        <p:txBody>
+          <a:bodyPr/>
+          <a:lstStyle/>
+          <a:p/>
+          <a:p>
+            <a:pPr lvl="1"/>
+            <a:r>
+              <a:t>Increased efficiency and productivity</a:t>
+            </a:r>
+          </a:p>
+          <a:p>
+            <a:pPr lvl="1"/>
+            <a:r>
+              <a:t>24/7 availability without fatigue</a:t>
+            </a:r>
+          </a:p>
+          <a:p>
+            <a:pPr lvl="1"/>
+            <a:r>
+              <a:t>Enhanced accuracy in data analysis</a:t>
+            </a:r>
+          </a:p>
+          <a:p>
+            <a:pPr lvl="1"/>
+            <a:r>
+              <a:t>Automation of repetitive tasks</a:t>
+            </a:r>
+          </a:p>
+          <a:p>
+            <a:pPr lvl="1"/>
+            <a:r>
+              <a:t>Personalized user experiences</a:t>
+            </a:r>
+          </a:p>
+          <a:p>
+            <a:pPr lvl="1"/>
+            <a:r>
+              <a:t>Solving complex problems beyond human capability</a:t>
+            </a:r>
+          </a:p>
+          <a:p>
+            <a:pPr lvl="1"/>
+            <a:r>
+              <a:t>Cost reduction in operations</a:t>
+            </a:r>
+          </a:p>
+        </p:txBody>
+      </p:sp>
+    </p:spTree>
+  </p:cSld>
+  <p:clrMapOvr>
+    <a:masterClrMapping/>
+  </p:clrMapOvr>
+</p:sld>
+</file>
+
+<file path=ppt/slides/slide9.xml><?xml version="1.0" encoding="utf-8"?>
+<p:sld xmlns:a="http://schemas.openxmlformats.org/drawingml/2006/main" xmlns:p="http://schemas.openxmlformats.org/presentationml/2006/main" xmlns:r="http://schemas.openxmlformats.org/officeDocument/2006/relationships">
+  <p:cSld>
+    <p:spTree>
+      <p:nvGrpSpPr>
+        <p:cNvPr id="1" name=""/>
+        <p:cNvGrpSpPr/>
+        <p:nvPr/>
+      </p:nvGrpSpPr>
+      <p:grpSpPr/>
+      <p:sp>
+        <p:nvSpPr>
+          <p:cNvPr id="2" name="Title 1"/>
+          <p:cNvSpPr>
+            <a:spLocks noGrp="1"/>
+          </p:cNvSpPr>
+          <p:nvPr>
+            <p:ph type="title"/>
+          </p:nvPr>
+        </p:nvSpPr>
+        <p:spPr/>
+        <p:txBody>
+          <a:bodyPr/>
+          <a:lstStyle/>
+          <a:p>
+            <a:r>
+              <a:t>Challenges and Concerns</a:t>
+            </a:r>
+          </a:p>
+        </p:txBody>
+      </p:sp>
+      <p:sp>
+        <p:nvSpPr>
+          <p:cNvPr id="3" name="Content Placeholder 2"/>
+          <p:cNvSpPr>
+            <a:spLocks noGrp="1"/>
+          </p:cNvSpPr>
+          <p:nvPr>
+            <p:ph idx="1"/>
+          </p:nvPr>
+        </p:nvSpPr>
+        <p:spPr/>
+        <p:txBody>
+          <a:bodyPr/>
+          <a:lstStyle/>
+          <a:p/>
+          <a:p>
+            <a:pPr lvl="1"/>
+            <a:r>
+              <a:t>Job displacement and economic impact</a:t>
+            </a:r>
+          </a:p>
+          <a:p>
+            <a:pPr lvl="1"/>
+            <a:r>
+              <a:t>Privacy and surveillance concerns</a:t>
+            </a:r>
+          </a:p>
+          <a:p>
+            <a:pPr lvl="1"/>
+            <a:r>
+              <a:t>Algorithmic bias and fairness</a:t>
+            </a:r>
+          </a:p>
+          <a:p>
+            <a:pPr lvl="1"/>
+            <a:r>
+              <a:t>Lack of transparency in decision-making</a:t>
+            </a:r>
+          </a:p>
+          <a:p>
+            <a:pPr lvl="1"/>
+            <a:r>
+              <a:t>Security vulnerabilities and hacking risks</a:t>
+            </a:r>
+          </a:p>
+          <a:p>
+            <a:pPr lvl="1"/>
+            <a:r>
+              <a:t>Ethical dilemmas in autonomous systems</a:t>
+            </a:r>
+          </a:p>
+          <a:p>
+            <a:pPr lvl="1"/>
+            <a:r>
+              <a:t>Over-reliance on technology</a:t>
             </a:r>
           </a:p>
         </p:txBody>

</xml_diff>

<commit_message>
Enhance presentation generation with iterative slide editing and new prompt system
- Added `interator_agent` for iterative slide editing based on user feedback.
- Updated prompts to include guidelines for iterative slide enhancement.
- Modified `test_agent.py` to support user-driven slide modifications.
- Introduced `SlideIterator` model for structured input during slide editing.
- Ensured `.gitignore` includes `.pptx` files to prevent tracking of generated presentations.
</commit_message>
<xml_diff>
--- a/test.pptx
+++ b/test.pptx
@@ -3116,7 +3116,7 @@
           <a:lstStyle/>
           <a:p>
             <a:r>
-              <a:t>Artificial Intelligence: Shaping the Future</a:t>
+              <a:t>Pokémon: Catch 'Em All!</a:t>
             </a:r>
           </a:p>
         </p:txBody>
@@ -3137,7 +3137,7 @@
           <a:lstStyle/>
           <a:p>
             <a:r>
-              <a:t>Exploring the revolutionary technology that's transforming our world</a:t>
+              <a:t>Exploring the Global Phenomenon That Changed Gaming Forever</a:t>
             </a:r>
           </a:p>
         </p:txBody>
@@ -3176,7 +3176,7 @@
           <a:lstStyle/>
           <a:p>
             <a:r>
-              <a:t>AI Ethics and Governance</a:t>
+              <a:t>Trading Card Game</a:t>
             </a:r>
           </a:p>
         </p:txBody>
@@ -3199,43 +3199,31 @@
           <a:p>
             <a:pPr lvl="1"/>
             <a:r>
-              <a:t>Need for transparent and accountable AI systems</a:t>
-            </a:r>
-          </a:p>
-          <a:p>
-            <a:pPr lvl="1"/>
-            <a:r>
-              <a:t>Ensuring fairness and preventing discrimination</a:t>
-            </a:r>
-          </a:p>
-          <a:p>
-            <a:pPr lvl="1"/>
-            <a:r>
-              <a:t>Protecting individual privacy rights</a:t>
-            </a:r>
-          </a:p>
-          <a:p>
-            <a:pPr lvl="1"/>
-            <a:r>
-              <a:t>Establishing regulatory frameworks</a:t>
-            </a:r>
-          </a:p>
-          <a:p>
-            <a:pPr lvl="1"/>
-            <a:r>
-              <a:t>Promoting responsible AI development</a:t>
-            </a:r>
-          </a:p>
-          <a:p>
-            <a:pPr lvl="1"/>
-            <a:r>
-              <a:t>Balancing innovation with safety</a:t>
-            </a:r>
-          </a:p>
-          <a:p>
-            <a:pPr lvl="1"/>
-            <a:r>
-              <a:t>International cooperation on AI standards</a:t>
+              <a:t>Launched in 1996 in Japan</a:t>
+            </a:r>
+          </a:p>
+          <a:p>
+            <a:pPr lvl="1"/>
+            <a:r>
+              <a:t>Over 30 billion cards sold</a:t>
+            </a:r>
+          </a:p>
+          <a:p>
+            <a:pPr lvl="1"/>
+            <a:r>
+              <a:t>Rare cards worth thousands</a:t>
+            </a:r>
+          </a:p>
+          <a:p>
+            <a:pPr lvl="1"/>
+            <a:r>
+              <a:t>Professional tournaments worldwide</a:t>
+            </a:r>
+          </a:p>
+          <a:p>
+            <a:pPr lvl="1"/>
+            <a:r>
+              <a:t>Still popular today</a:t>
             </a:r>
           </a:p>
         </p:txBody>
@@ -3274,7 +3262,7 @@
           <a:lstStyle/>
           <a:p>
             <a:r>
-              <a:t>The Future of AI</a:t>
+              <a:t>The Future of Pokémon</a:t>
             </a:r>
           </a:p>
         </p:txBody>
@@ -3297,43 +3285,43 @@
           <a:p>
             <a:pPr lvl="1"/>
             <a:r>
-              <a:t>Continued advancement in machine learning capabilities</a:t>
-            </a:r>
-          </a:p>
-          <a:p>
-            <a:pPr lvl="1"/>
-            <a:r>
-              <a:t>Integration with Internet of Things (IoT)</a:t>
-            </a:r>
-          </a:p>
-          <a:p>
-            <a:pPr lvl="1"/>
-            <a:r>
-              <a:t>Enhanced human-AI collaboration</a:t>
-            </a:r>
-          </a:p>
-          <a:p>
-            <a:pPr lvl="1"/>
-            <a:r>
-              <a:t>Breakthrough in general AI research</a:t>
-            </a:r>
-          </a:p>
-          <a:p>
-            <a:pPr lvl="1"/>
-            <a:r>
-              <a:t>Quantum computing revolutionizing AI</a:t>
-            </a:r>
-          </a:p>
-          <a:p>
-            <a:pPr lvl="1"/>
-            <a:r>
-              <a:t>AI in space exploration and scientific discovery</a:t>
-            </a:r>
-          </a:p>
-          <a:p>
-            <a:pPr lvl="1"/>
-            <a:r>
-              <a:t>Potential for solving global challenges</a:t>
+              <a:t>Pokémon HOME: Cloud service connecting all games</a:t>
+            </a:r>
+          </a:p>
+          <a:p>
+            <a:pPr lvl="1"/>
+            <a:r>
+              <a:t>Scarlet and Violet (2022) open-world gameplay</a:t>
+            </a:r>
+          </a:p>
+          <a:p>
+            <a:pPr lvl="1"/>
+            <a:r>
+              <a:t>Pokémon Legends: Arceus prequel</a:t>
+            </a:r>
+          </a:p>
+          <a:p>
+            <a:pPr lvl="1"/>
+            <a:r>
+              <a:t>Nintendo Switch Online integration</a:t>
+            </a:r>
+          </a:p>
+          <a:p>
+            <a:pPr lvl="1"/>
+            <a:r>
+              <a:t>Mobile games expanding with Pokémon Unite</a:t>
+            </a:r>
+          </a:p>
+          <a:p>
+            <a:pPr lvl="1"/>
+            <a:r>
+              <a:t>Augmented reality in Pokémon GO</a:t>
+            </a:r>
+          </a:p>
+          <a:p>
+            <a:pPr lvl="1"/>
+            <a:r>
+              <a:t>Cross-platform connectivity features</a:t>
             </a:r>
           </a:p>
         </p:txBody>
@@ -3372,7 +3360,7 @@
           <a:lstStyle/>
           <a:p>
             <a:r>
-              <a:t>Preparing for an AI Future</a:t>
+              <a:t>Why Pokémon Endures</a:t>
             </a:r>
           </a:p>
         </p:txBody>
@@ -3395,43 +3383,31 @@
           <a:p>
             <a:pPr lvl="1"/>
             <a:r>
-              <a:t>Developing AI literacy and digital skills</a:t>
-            </a:r>
-          </a:p>
-          <a:p>
-            <a:pPr lvl="1"/>
-            <a:r>
-              <a:t>Emphasizing human creativity and emotional intelligence</a:t>
-            </a:r>
-          </a:p>
-          <a:p>
-            <a:pPr lvl="1"/>
-            <a:r>
-              <a:t>Creating adaptive education systems</a:t>
-            </a:r>
-          </a:p>
-          <a:p>
-            <a:pPr lvl="1"/>
-            <a:r>
-              <a:t>Establishing ethical guidelines</a:t>
-            </a:r>
-          </a:p>
-          <a:p>
-            <a:pPr lvl="1"/>
-            <a:r>
-              <a:t>Investing in AI research and development</a:t>
-            </a:r>
-          </a:p>
-          <a:p>
-            <a:pPr lvl="1"/>
-            <a:r>
-              <a:t>Building inclusive AI for everyone</a:t>
-            </a:r>
-          </a:p>
-          <a:p>
-            <a:pPr lvl="1"/>
-            <a:r>
-              <a:t>Fostering human-AI partnership</a:t>
+              <a:t>Nostalgia for original fans</a:t>
+            </a:r>
+          </a:p>
+          <a:p>
+            <a:pPr lvl="1"/>
+            <a:r>
+              <a:t>Simple yet deep gameplay</a:t>
+            </a:r>
+          </a:p>
+          <a:p>
+            <a:pPr lvl="1"/>
+            <a:r>
+              <a:t>Constant innovation</a:t>
+            </a:r>
+          </a:p>
+          <a:p>
+            <a:pPr lvl="1"/>
+            <a:r>
+              <a:t>Strong community</a:t>
+            </a:r>
+          </a:p>
+          <a:p>
+            <a:pPr lvl="1"/>
+            <a:r>
+              <a:t>Timeless appeal</a:t>
             </a:r>
           </a:p>
         </p:txBody>
@@ -3470,29 +3446,7 @@
           <a:lstStyle/>
           <a:p>
             <a:r>
-              <a:t>Conclusion</a:t>
-            </a:r>
-          </a:p>
-        </p:txBody>
-      </p:sp>
-      <p:sp>
-        <p:nvSpPr>
-          <p:cNvPr id="3" name="Content Placeholder 2"/>
-          <p:cNvSpPr>
-            <a:spLocks noGrp="1"/>
-          </p:cNvSpPr>
-          <p:nvPr>
-            <p:ph idx="1"/>
-          </p:nvPr>
-        </p:nvSpPr>
-        <p:spPr/>
-        <p:txBody>
-          <a:bodyPr/>
-          <a:lstStyle/>
-          <a:p/>
-          <a:p>
-            <a:r>
-              <a:t>Artificial Intelligence represents one of the most transformative technologies of our time. While it presents incredible opportunities for advancement across all sectors of society, it also requires careful consideration of ethical implications and responsible development. By understanding AI's capabilities and limitations, we can harness its power to create a better future for humanity.</a:t>
+              <a:t>Thank You!</a:t>
             </a:r>
           </a:p>
         </p:txBody>
@@ -3531,7 +3485,7 @@
           <a:lstStyle/>
           <a:p>
             <a:r>
-              <a:t>What is Artificial Intelligence?</a:t>
+              <a:t>What is Pokémon?</a:t>
             </a:r>
           </a:p>
         </p:txBody>
@@ -3554,25 +3508,31 @@
           <a:p>
             <a:pPr lvl="1"/>
             <a:r>
-              <a:t>Computer systems that can perform tasks requiring human intelligence</a:t>
-            </a:r>
-          </a:p>
-          <a:p>
-            <a:pPr lvl="1"/>
-            <a:r>
-              <a:t>Includes learning, reasoning, problem-solving, and decision-making</a:t>
-            </a:r>
-          </a:p>
-          <a:p>
-            <a:pPr lvl="1"/>
-            <a:r>
-              <a:t>Ranges from narrow AI (specific tasks) to general AI (human-like intelligence)</a:t>
-            </a:r>
-          </a:p>
-          <a:p>
-            <a:pPr lvl="1"/>
-            <a:r>
-              <a:t>Combines computer science, mathematics, psychology, and neuroscience</a:t>
+              <a:t>Media franchise created by Satoshi Tajiri in 1995</a:t>
+            </a:r>
+          </a:p>
+          <a:p>
+            <a:pPr lvl="1"/>
+            <a:r>
+              <a:t>Short for 'Pocket Monsters' in Japanese</a:t>
+            </a:r>
+          </a:p>
+          <a:p>
+            <a:pPr lvl="1"/>
+            <a:r>
+              <a:t>Features fictional creatures called Pokémon</a:t>
+            </a:r>
+          </a:p>
+          <a:p>
+            <a:pPr lvl="1"/>
+            <a:r>
+              <a:t>Trainers catch and battle Pokémon</a:t>
+            </a:r>
+          </a:p>
+          <a:p>
+            <a:pPr lvl="1"/>
+            <a:r>
+              <a:t>Spanning games, TV shows, movies, cards, and more</a:t>
             </a:r>
           </a:p>
         </p:txBody>
@@ -3611,7 +3571,7 @@
           <a:lstStyle/>
           <a:p>
             <a:r>
-              <a:t>Brief History of AI</a:t>
+              <a:t>The Beginning: 1996-1998</a:t>
             </a:r>
           </a:p>
         </p:txBody>
@@ -3634,37 +3594,31 @@
           <a:p>
             <a:pPr lvl="1"/>
             <a:r>
-              <a:t>1950s: Alan Turing proposes the Turing Test</a:t>
-            </a:r>
-          </a:p>
-          <a:p>
-            <a:pPr lvl="1"/>
-            <a:r>
-              <a:t>1956: Term 'Artificial Intelligence' coined at Dartmouth Conference</a:t>
-            </a:r>
-          </a:p>
-          <a:p>
-            <a:pPr lvl="1"/>
-            <a:r>
-              <a:t>1997: Deep Blue defeats world chess champion</a:t>
-            </a:r>
-          </a:p>
-          <a:p>
-            <a:pPr lvl="1"/>
-            <a:r>
-              <a:t>2011: IBM Watson wins Jeopardy!</a:t>
-            </a:r>
-          </a:p>
-          <a:p>
-            <a:pPr lvl="1"/>
-            <a:r>
-              <a:t>2016: AlphaGo defeats Go world champion</a:t>
-            </a:r>
-          </a:p>
-          <a:p>
-            <a:pPr lvl="1"/>
-            <a:r>
-              <a:t>2022: ChatGPT launches, bringing AI to mainstream</a:t>
+              <a:t>Pokémon Red and Green released in Japan (1996)</a:t>
+            </a:r>
+          </a:p>
+          <a:p>
+            <a:pPr lvl="1"/>
+            <a:r>
+              <a:t>Pokémon Blue followed with enhanced graphics</a:t>
+            </a:r>
+          </a:p>
+          <a:p>
+            <a:pPr lvl="1"/>
+            <a:r>
+              <a:t>Revolutionary Game Boy RPG concept</a:t>
+            </a:r>
+          </a:p>
+          <a:p>
+            <a:pPr lvl="1"/>
+            <a:r>
+              <a:t>Trading feature between games</a:t>
+            </a:r>
+          </a:p>
+          <a:p>
+            <a:pPr lvl="1"/>
+            <a:r>
+              <a:t>Slogan: 'Gotta Catch 'Em All!'</a:t>
             </a:r>
           </a:p>
         </p:txBody>
@@ -3703,7 +3657,7 @@
           <a:lstStyle/>
           <a:p>
             <a:r>
-              <a:t>Types of AI</a:t>
+              <a:t>Global Expansion</a:t>
             </a:r>
           </a:p>
         </p:txBody>
@@ -3726,31 +3680,31 @@
           <a:p>
             <a:pPr lvl="1"/>
             <a:r>
-              <a:t>Narrow AI: Designed for specific tasks (Siri, Netflix recommendations)</a:t>
-            </a:r>
-          </a:p>
-          <a:p>
-            <a:pPr lvl="1"/>
-            <a:r>
-              <a:t>General AI: Hypothetical AI with human-level intelligence across all domains</a:t>
-            </a:r>
-          </a:p>
-          <a:p>
-            <a:pPr lvl="1"/>
-            <a:r>
-              <a:t>Super AI: Theoretical AI surpassing human intelligence</a:t>
-            </a:r>
-          </a:p>
-          <a:p>
-            <a:pPr lvl="1"/>
-            <a:r>
-              <a:t>Machine Learning: Algorithms that improve through experience</a:t>
-            </a:r>
-          </a:p>
-          <a:p>
-            <a:pPr lvl="1"/>
-            <a:r>
-              <a:t>Deep Learning: Neural networks with multiple layers</a:t>
+              <a:t>Pokémon Red and Blue hit North America (1998)</a:t>
+            </a:r>
+          </a:p>
+          <a:p>
+            <a:pPr lvl="1"/>
+            <a:r>
+              <a:t>Anime series premiered worldwide</a:t>
+            </a:r>
+          </a:p>
+          <a:p>
+            <a:pPr lvl="1"/>
+            <a:r>
+              <a:t>Trading Card Game launched</a:t>
+            </a:r>
+          </a:p>
+          <a:p>
+            <a:pPr lvl="1"/>
+            <a:r>
+              <a:t>Pokémon became a cultural phenomenon</a:t>
+            </a:r>
+          </a:p>
+          <a:p>
+            <a:pPr lvl="1"/>
+            <a:r>
+              <a:t>Pikachu became the franchise mascot</a:t>
             </a:r>
           </a:p>
         </p:txBody>
@@ -3789,7 +3743,7 @@
           <a:lstStyle/>
           <a:p>
             <a:r>
-              <a:t>How AI Works</a:t>
+              <a:t>Core Gameplay Mechanics</a:t>
             </a:r>
           </a:p>
         </p:txBody>
@@ -3812,37 +3766,31 @@
           <a:p>
             <a:pPr lvl="1"/>
             <a:r>
-              <a:t>Data Collection: Gathering relevant information</a:t>
-            </a:r>
-          </a:p>
-          <a:p>
-            <a:pPr lvl="1"/>
-            <a:r>
-              <a:t>Training: Teaching algorithms using data patterns</a:t>
-            </a:r>
-          </a:p>
-          <a:p>
-            <a:pPr lvl="1"/>
-            <a:r>
-              <a:t>Neural Networks: Simulating human brain connections</a:t>
-            </a:r>
-          </a:p>
-          <a:p>
-            <a:pPr lvl="1"/>
-            <a:r>
-              <a:t>Natural Language Processing: Understanding human language</a:t>
-            </a:r>
-          </a:p>
-          <a:p>
-            <a:pPr lvl="1"/>
-            <a:r>
-              <a:t>Computer Vision: Interpreting visual information</a:t>
-            </a:r>
-          </a:p>
-          <a:p>
-            <a:pPr lvl="1"/>
-            <a:r>
-              <a:t>Reinforcement Learning: Learning through trial and error</a:t>
+              <a:t>Capture wild Pokémon using Poké Balls</a:t>
+            </a:r>
+          </a:p>
+          <a:p>
+            <a:pPr lvl="1"/>
+            <a:r>
+              <a:t>Train Pokémon to increase levels</a:t>
+            </a:r>
+          </a:p>
+          <a:p>
+            <a:pPr lvl="1"/>
+            <a:r>
+              <a:t>Battle system with type advantages</a:t>
+            </a:r>
+          </a:p>
+          <a:p>
+            <a:pPr lvl="1"/>
+            <a:r>
+              <a:t>Evolution makes Pokémon stronger</a:t>
+            </a:r>
+          </a:p>
+          <a:p>
+            <a:pPr lvl="1"/>
+            <a:r>
+              <a:t>Trade to complete your Pokédex</a:t>
             </a:r>
           </a:p>
         </p:txBody>
@@ -3881,40 +3829,19 @@
           <a:lstStyle/>
           <a:p>
             <a:r>
-              <a:t>AI vs Traditional Programming</a:t>
-            </a:r>
-          </a:p>
-        </p:txBody>
-      </p:sp>
-      <p:sp>
-        <p:nvSpPr>
-          <p:cNvPr id="3" name="Text Placeholder 2"/>
-          <p:cNvSpPr>
-            <a:spLocks noGrp="1"/>
-          </p:cNvSpPr>
-          <p:nvPr>
-            <p:ph type="body" idx="1"/>
-          </p:nvPr>
-        </p:nvSpPr>
-        <p:spPr/>
-        <p:txBody>
-          <a:bodyPr/>
-          <a:lstStyle/>
-          <a:p>
-            <a:r>
-              <a:t>Traditional Programming</a:t>
-            </a:r>
-          </a:p>
-        </p:txBody>
-      </p:sp>
-      <p:sp>
-        <p:nvSpPr>
-          <p:cNvPr id="4" name="Content Placeholder 3"/>
-          <p:cNvSpPr>
-            <a:spLocks noGrp="1"/>
-          </p:cNvSpPr>
-          <p:nvPr>
-            <p:ph idx="2" sz="half"/>
+              <a:t>Regional Pokémon Variants</a:t>
+            </a:r>
+          </a:p>
+        </p:txBody>
+      </p:sp>
+      <p:sp>
+        <p:nvSpPr>
+          <p:cNvPr id="3" name="Content Placeholder 2"/>
+          <p:cNvSpPr>
+            <a:spLocks noGrp="1"/>
+          </p:cNvSpPr>
+          <p:nvPr>
+            <p:ph idx="1"/>
           </p:nvPr>
         </p:nvSpPr>
         <p:spPr/>
@@ -3923,101 +3850,38 @@
           <a:lstStyle/>
           <a:p/>
           <a:p>
-            <a:pPr lvl="1"/>
-            <a:r>
-              <a:t>Explicit rules defined by programmers</a:t>
-            </a:r>
-          </a:p>
-          <a:p>
-            <a:pPr lvl="1"/>
-            <a:r>
-              <a:t>Fixed logic and decision trees</a:t>
-            </a:r>
-          </a:p>
-          <a:p>
-            <a:pPr lvl="1"/>
-            <a:r>
-              <a:t>Limited adaptability</a:t>
-            </a:r>
-          </a:p>
-          <a:p>
-            <a:pPr lvl="1"/>
-            <a:r>
-              <a:t>Requires manual updates for changes</a:t>
-            </a:r>
-          </a:p>
-          <a:p>
-            <a:pPr lvl="1"/>
-            <a:r>
-              <a:t>Predictable outcomes based on code</a:t>
-            </a:r>
-          </a:p>
-        </p:txBody>
-      </p:sp>
-      <p:sp>
-        <p:nvSpPr>
-          <p:cNvPr id="5" name="Text Placeholder 4"/>
-          <p:cNvSpPr>
-            <a:spLocks noGrp="1"/>
-          </p:cNvSpPr>
-          <p:nvPr>
-            <p:ph type="body" idx="3" sz="quarter"/>
-          </p:nvPr>
-        </p:nvSpPr>
-        <p:spPr/>
-        <p:txBody>
-          <a:bodyPr/>
-          <a:lstStyle/>
-          <a:p>
-            <a:r>
-              <a:t>Artificial Intelligence</a:t>
-            </a:r>
-          </a:p>
-        </p:txBody>
-      </p:sp>
-      <p:sp>
-        <p:nvSpPr>
-          <p:cNvPr id="6" name="Content Placeholder 5"/>
-          <p:cNvSpPr>
-            <a:spLocks noGrp="1"/>
-          </p:cNvSpPr>
-          <p:nvPr>
-            <p:ph idx="4" sz="quarter"/>
-          </p:nvPr>
-        </p:nvSpPr>
-        <p:spPr/>
-        <p:txBody>
-          <a:bodyPr/>
-          <a:lstStyle/>
-          <a:p/>
-          <a:p>
-            <a:pPr lvl="1"/>
-            <a:r>
-              <a:t>Learns patterns from data</a:t>
-            </a:r>
-          </a:p>
-          <a:p>
-            <a:pPr lvl="1"/>
-            <a:r>
-              <a:t>Adapts and improves over time</a:t>
-            </a:r>
-          </a:p>
-          <a:p>
-            <a:pPr lvl="1"/>
-            <a:r>
-              <a:t>Handles uncertainty and variation</a:t>
-            </a:r>
-          </a:p>
-          <a:p>
-            <a:pPr lvl="1"/>
-            <a:r>
-              <a:t>Autonomous decision-making</a:t>
-            </a:r>
-          </a:p>
-          <a:p>
-            <a:pPr lvl="1"/>
-            <a:r>
-              <a:t>Can discover unexpected solutions</a:t>
+            <a:r>
+              <a:t>Beyond the original 150, Pokémon introduced regional variants that reimagined familiar species</a:t>
+            </a:r>
+          </a:p>
+          <a:p>
+            <a:pPr lvl="1"/>
+            <a:r>
+              <a:t>Alolan forms: Tropical variants from Generation VII</a:t>
+            </a:r>
+          </a:p>
+          <a:p>
+            <a:pPr lvl="1"/>
+            <a:r>
+              <a:t>Galarian forms: British-inspired variants from Generation VIII</a:t>
+            </a:r>
+          </a:p>
+          <a:p>
+            <a:pPr lvl="1"/>
+            <a:r>
+              <a:t>Hisuian forms: Historical variants from Pokémon Legends: Arceus</a:t>
+            </a:r>
+          </a:p>
+          <a:p>
+            <a:pPr lvl="1"/>
+            <a:r>
+              <a:t>Regional variants have different types and abilities</a:t>
+            </a:r>
+          </a:p>
+          <a:p>
+            <a:pPr lvl="1"/>
+            <a:r>
+              <a:t>Shows how Pokémon adapt to different environments</a:t>
             </a:r>
           </a:p>
         </p:txBody>
@@ -4056,7 +3920,7 @@
           <a:lstStyle/>
           <a:p>
             <a:r>
-              <a:t>Real-World Applications</a:t>
+              <a:t>Evolution Over Generations</a:t>
             </a:r>
           </a:p>
         </p:txBody>
@@ -4079,37 +3943,31 @@
           <a:p>
             <a:pPr lvl="1"/>
             <a:r>
-              <a:t>Healthcare: Disease diagnosis, drug discovery, personalized treatment</a:t>
-            </a:r>
-          </a:p>
-          <a:p>
-            <a:pPr lvl="1"/>
-            <a:r>
-              <a:t>Transportation: Self-driving cars, traffic optimization, route planning</a:t>
-            </a:r>
-          </a:p>
-          <a:p>
-            <a:pPr lvl="1"/>
-            <a:r>
-              <a:t>Finance: Fraud detection, algorithmic trading, credit scoring</a:t>
-            </a:r>
-          </a:p>
-          <a:p>
-            <a:pPr lvl="1"/>
-            <a:r>
-              <a:t>Education: Personalized learning, automated grading, tutoring systems</a:t>
-            </a:r>
-          </a:p>
-          <a:p>
-            <a:pPr lvl="1"/>
-            <a:r>
-              <a:t>Entertainment: Content recommendation, game AI, music composition</a:t>
-            </a:r>
-          </a:p>
-          <a:p>
-            <a:pPr lvl="1"/>
-            <a:r>
-              <a:t>Manufacturing: Quality control, predictive maintenance, robotics</a:t>
+              <a:t>Generation II: Johto region (1999)</a:t>
+            </a:r>
+          </a:p>
+          <a:p>
+            <a:pPr lvl="1"/>
+            <a:r>
+              <a:t>Generation III: Hoenn region (2002)</a:t>
+            </a:r>
+          </a:p>
+          <a:p>
+            <a:pPr lvl="1"/>
+            <a:r>
+              <a:t>Generation IV: Sinnoh region (2006)</a:t>
+            </a:r>
+          </a:p>
+          <a:p>
+            <a:pPr lvl="1"/>
+            <a:r>
+              <a:t>Generation VIII: Galar region (2019)</a:t>
+            </a:r>
+          </a:p>
+          <a:p>
+            <a:pPr lvl="1"/>
+            <a:r>
+              <a:t>Over 900 Pokémon species today</a:t>
             </a:r>
           </a:p>
         </p:txBody>
@@ -4148,7 +4006,7 @@
           <a:lstStyle/>
           <a:p>
             <a:r>
-              <a:t>Benefits of AI</a:t>
+              <a:t>Battle System Explained</a:t>
             </a:r>
           </a:p>
         </p:txBody>
@@ -4171,43 +4029,31 @@
           <a:p>
             <a:pPr lvl="1"/>
             <a:r>
-              <a:t>Increased efficiency and productivity</a:t>
-            </a:r>
-          </a:p>
-          <a:p>
-            <a:pPr lvl="1"/>
-            <a:r>
-              <a:t>24/7 availability without fatigue</a:t>
-            </a:r>
-          </a:p>
-          <a:p>
-            <a:pPr lvl="1"/>
-            <a:r>
-              <a:t>Enhanced accuracy in data analysis</a:t>
-            </a:r>
-          </a:p>
-          <a:p>
-            <a:pPr lvl="1"/>
-            <a:r>
-              <a:t>Automation of repetitive tasks</a:t>
-            </a:r>
-          </a:p>
-          <a:p>
-            <a:pPr lvl="1"/>
-            <a:r>
-              <a:t>Personalized user experiences</a:t>
-            </a:r>
-          </a:p>
-          <a:p>
-            <a:pPr lvl="1"/>
-            <a:r>
-              <a:t>Solving complex problems beyond human capability</a:t>
-            </a:r>
-          </a:p>
-          <a:p>
-            <a:pPr lvl="1"/>
-            <a:r>
-              <a:t>Cost reduction in operations</a:t>
+              <a:t>Turn-based combat system</a:t>
+            </a:r>
+          </a:p>
+          <a:p>
+            <a:pPr lvl="1"/>
+            <a:r>
+              <a:t>18 different Pokémon types</a:t>
+            </a:r>
+          </a:p>
+          <a:p>
+            <a:pPr lvl="1"/>
+            <a:r>
+              <a:t>Rock-Paper-Scissors mechanics</a:t>
+            </a:r>
+          </a:p>
+          <a:p>
+            <a:pPr lvl="1"/>
+            <a:r>
+              <a:t>Status effects and special abilities</a:t>
+            </a:r>
+          </a:p>
+          <a:p>
+            <a:pPr lvl="1"/>
+            <a:r>
+              <a:t>Competitive battling scene</a:t>
             </a:r>
           </a:p>
         </p:txBody>
@@ -4246,7 +4092,7 @@
           <a:lstStyle/>
           <a:p>
             <a:r>
-              <a:t>Challenges and Concerns</a:t>
+              <a:t>Cultural Impact</a:t>
             </a:r>
           </a:p>
         </p:txBody>
@@ -4269,43 +4115,31 @@
           <a:p>
             <a:pPr lvl="1"/>
             <a:r>
-              <a:t>Job displacement and economic impact</a:t>
-            </a:r>
-          </a:p>
-          <a:p>
-            <a:pPr lvl="1"/>
-            <a:r>
-              <a:t>Privacy and surveillance concerns</a:t>
-            </a:r>
-          </a:p>
-          <a:p>
-            <a:pPr lvl="1"/>
-            <a:r>
-              <a:t>Algorithmic bias and fairness</a:t>
-            </a:r>
-          </a:p>
-          <a:p>
-            <a:pPr lvl="1"/>
-            <a:r>
-              <a:t>Lack of transparency in decision-making</a:t>
-            </a:r>
-          </a:p>
-          <a:p>
-            <a:pPr lvl="1"/>
-            <a:r>
-              <a:t>Security vulnerabilities and hacking risks</a:t>
-            </a:r>
-          </a:p>
-          <a:p>
-            <a:pPr lvl="1"/>
-            <a:r>
-              <a:t>Ethical dilemmas in autonomous systems</a:t>
-            </a:r>
-          </a:p>
-          <a:p>
-            <a:pPr lvl="1"/>
-            <a:r>
-              <a:t>Over-reliance on technology</a:t>
+              <a:t>Pokémon GO mobile phenomenon (2016)</a:t>
+            </a:r>
+          </a:p>
+          <a:p>
+            <a:pPr lvl="1"/>
+            <a:r>
+              <a:t>Detective Pikachu movie success</a:t>
+            </a:r>
+          </a:p>
+          <a:p>
+            <a:pPr lvl="1"/>
+            <a:r>
+              <a:t>Merchandise worth billions</a:t>
+            </a:r>
+          </a:p>
+          <a:p>
+            <a:pPr lvl="1"/>
+            <a:r>
+              <a:t>Theme parks and attractions</a:t>
+            </a:r>
+          </a:p>
+          <a:p>
+            <a:pPr lvl="1"/>
+            <a:r>
+              <a:t>Global community of fans</a:t>
             </a:r>
           </a:p>
         </p:txBody>

</xml_diff>

<commit_message>
added improvements to slide enhancement feature
Signed-off-by: aritroCoder <ogcodinggod@gmail.com>
</commit_message>
<xml_diff>
--- a/test.pptx
+++ b/test.pptx
@@ -14,10 +14,6 @@
     <p:sldId id="262" r:id="rId13"/>
     <p:sldId id="263" r:id="rId14"/>
     <p:sldId id="264" r:id="rId15"/>
-    <p:sldId id="265" r:id="rId16"/>
-    <p:sldId id="266" r:id="rId17"/>
-    <p:sldId id="267" r:id="rId18"/>
-    <p:sldId id="268" r:id="rId19"/>
   </p:sldIdLst>
   <p:sldSz cx="9144000" cy="6858000" type="screen4x3"/>
   <p:notesSz cx="6858000" cy="9144000"/>
@@ -3107,66 +3103,6 @@
             <a:spLocks noGrp="1"/>
           </p:cNvSpPr>
           <p:nvPr>
-            <p:ph type="ctrTitle"/>
-          </p:nvPr>
-        </p:nvSpPr>
-        <p:spPr/>
-        <p:txBody>
-          <a:bodyPr/>
-          <a:lstStyle/>
-          <a:p>
-            <a:r>
-              <a:t>Pokémon: Catch 'Em All!</a:t>
-            </a:r>
-          </a:p>
-        </p:txBody>
-      </p:sp>
-      <p:sp>
-        <p:nvSpPr>
-          <p:cNvPr id="3" name="Subtitle 2"/>
-          <p:cNvSpPr>
-            <a:spLocks noGrp="1"/>
-          </p:cNvSpPr>
-          <p:nvPr>
-            <p:ph type="subTitle" idx="1"/>
-          </p:nvPr>
-        </p:nvSpPr>
-        <p:spPr/>
-        <p:txBody>
-          <a:bodyPr/>
-          <a:lstStyle/>
-          <a:p>
-            <a:r>
-              <a:t>Exploring the Global Phenomenon That Changed Gaming Forever</a:t>
-            </a:r>
-          </a:p>
-        </p:txBody>
-      </p:sp>
-    </p:spTree>
-  </p:cSld>
-  <p:clrMapOvr>
-    <a:masterClrMapping/>
-  </p:clrMapOvr>
-</p:sld>
-</file>
-
-<file path=ppt/slides/slide10.xml><?xml version="1.0" encoding="utf-8"?>
-<p:sld xmlns:a="http://schemas.openxmlformats.org/drawingml/2006/main" xmlns:p="http://schemas.openxmlformats.org/presentationml/2006/main" xmlns:r="http://schemas.openxmlformats.org/officeDocument/2006/relationships">
-  <p:cSld>
-    <p:spTree>
-      <p:nvGrpSpPr>
-        <p:cNvPr id="1" name=""/>
-        <p:cNvGrpSpPr/>
-        <p:nvPr/>
-      </p:nvGrpSpPr>
-      <p:grpSpPr/>
-      <p:sp>
-        <p:nvSpPr>
-          <p:cNvPr id="2" name="Title 1"/>
-          <p:cNvSpPr>
-            <a:spLocks noGrp="1"/>
-          </p:cNvSpPr>
-          <p:nvPr>
             <p:ph type="title"/>
           </p:nvPr>
         </p:nvSpPr>
@@ -3176,7 +3112,7 @@
           <a:lstStyle/>
           <a:p>
             <a:r>
-              <a:t>Trading Card Game</a:t>
+              <a:t>The Avengers: Earth's Mightiest Heroes</a:t>
             </a:r>
           </a:p>
         </p:txBody>
@@ -3197,256 +3133,8 @@
           <a:lstStyle/>
           <a:p/>
           <a:p>
-            <a:pPr lvl="1"/>
-            <a:r>
-              <a:t>Launched in 1996 in Japan</a:t>
-            </a:r>
-          </a:p>
-          <a:p>
-            <a:pPr lvl="1"/>
-            <a:r>
-              <a:t>Over 30 billion cards sold</a:t>
-            </a:r>
-          </a:p>
-          <a:p>
-            <a:pPr lvl="1"/>
-            <a:r>
-              <a:t>Rare cards worth thousands</a:t>
-            </a:r>
-          </a:p>
-          <a:p>
-            <a:pPr lvl="1"/>
-            <a:r>
-              <a:t>Professional tournaments worldwide</a:t>
-            </a:r>
-          </a:p>
-          <a:p>
-            <a:pPr lvl="1"/>
-            <a:r>
-              <a:t>Still popular today</a:t>
-            </a:r>
-          </a:p>
-        </p:txBody>
-      </p:sp>
-    </p:spTree>
-  </p:cSld>
-  <p:clrMapOvr>
-    <a:masterClrMapping/>
-  </p:clrMapOvr>
-</p:sld>
-</file>
-
-<file path=ppt/slides/slide11.xml><?xml version="1.0" encoding="utf-8"?>
-<p:sld xmlns:a="http://schemas.openxmlformats.org/drawingml/2006/main" xmlns:p="http://schemas.openxmlformats.org/presentationml/2006/main" xmlns:r="http://schemas.openxmlformats.org/officeDocument/2006/relationships">
-  <p:cSld>
-    <p:spTree>
-      <p:nvGrpSpPr>
-        <p:cNvPr id="1" name=""/>
-        <p:cNvGrpSpPr/>
-        <p:nvPr/>
-      </p:nvGrpSpPr>
-      <p:grpSpPr/>
-      <p:sp>
-        <p:nvSpPr>
-          <p:cNvPr id="2" name="Title 1"/>
-          <p:cNvSpPr>
-            <a:spLocks noGrp="1"/>
-          </p:cNvSpPr>
-          <p:nvPr>
-            <p:ph type="title"/>
-          </p:nvPr>
-        </p:nvSpPr>
-        <p:spPr/>
-        <p:txBody>
-          <a:bodyPr/>
-          <a:lstStyle/>
-          <a:p>
-            <a:r>
-              <a:t>The Future of Pokémon</a:t>
-            </a:r>
-          </a:p>
-        </p:txBody>
-      </p:sp>
-      <p:sp>
-        <p:nvSpPr>
-          <p:cNvPr id="3" name="Content Placeholder 2"/>
-          <p:cNvSpPr>
-            <a:spLocks noGrp="1"/>
-          </p:cNvSpPr>
-          <p:nvPr>
-            <p:ph idx="1"/>
-          </p:nvPr>
-        </p:nvSpPr>
-        <p:spPr/>
-        <p:txBody>
-          <a:bodyPr/>
-          <a:lstStyle/>
-          <a:p/>
-          <a:p>
-            <a:pPr lvl="1"/>
-            <a:r>
-              <a:t>Pokémon HOME: Cloud service connecting all games</a:t>
-            </a:r>
-          </a:p>
-          <a:p>
-            <a:pPr lvl="1"/>
-            <a:r>
-              <a:t>Scarlet and Violet (2022) open-world gameplay</a:t>
-            </a:r>
-          </a:p>
-          <a:p>
-            <a:pPr lvl="1"/>
-            <a:r>
-              <a:t>Pokémon Legends: Arceus prequel</a:t>
-            </a:r>
-          </a:p>
-          <a:p>
-            <a:pPr lvl="1"/>
-            <a:r>
-              <a:t>Nintendo Switch Online integration</a:t>
-            </a:r>
-          </a:p>
-          <a:p>
-            <a:pPr lvl="1"/>
-            <a:r>
-              <a:t>Mobile games expanding with Pokémon Unite</a:t>
-            </a:r>
-          </a:p>
-          <a:p>
-            <a:pPr lvl="1"/>
-            <a:r>
-              <a:t>Augmented reality in Pokémon GO</a:t>
-            </a:r>
-          </a:p>
-          <a:p>
-            <a:pPr lvl="1"/>
-            <a:r>
-              <a:t>Cross-platform connectivity features</a:t>
-            </a:r>
-          </a:p>
-        </p:txBody>
-      </p:sp>
-    </p:spTree>
-  </p:cSld>
-  <p:clrMapOvr>
-    <a:masterClrMapping/>
-  </p:clrMapOvr>
-</p:sld>
-</file>
-
-<file path=ppt/slides/slide12.xml><?xml version="1.0" encoding="utf-8"?>
-<p:sld xmlns:a="http://schemas.openxmlformats.org/drawingml/2006/main" xmlns:p="http://schemas.openxmlformats.org/presentationml/2006/main" xmlns:r="http://schemas.openxmlformats.org/officeDocument/2006/relationships">
-  <p:cSld>
-    <p:spTree>
-      <p:nvGrpSpPr>
-        <p:cNvPr id="1" name=""/>
-        <p:cNvGrpSpPr/>
-        <p:nvPr/>
-      </p:nvGrpSpPr>
-      <p:grpSpPr/>
-      <p:sp>
-        <p:nvSpPr>
-          <p:cNvPr id="2" name="Title 1"/>
-          <p:cNvSpPr>
-            <a:spLocks noGrp="1"/>
-          </p:cNvSpPr>
-          <p:nvPr>
-            <p:ph type="title"/>
-          </p:nvPr>
-        </p:nvSpPr>
-        <p:spPr/>
-        <p:txBody>
-          <a:bodyPr/>
-          <a:lstStyle/>
-          <a:p>
-            <a:r>
-              <a:t>Why Pokémon Endures</a:t>
-            </a:r>
-          </a:p>
-        </p:txBody>
-      </p:sp>
-      <p:sp>
-        <p:nvSpPr>
-          <p:cNvPr id="3" name="Content Placeholder 2"/>
-          <p:cNvSpPr>
-            <a:spLocks noGrp="1"/>
-          </p:cNvSpPr>
-          <p:nvPr>
-            <p:ph idx="1"/>
-          </p:nvPr>
-        </p:nvSpPr>
-        <p:spPr/>
-        <p:txBody>
-          <a:bodyPr/>
-          <a:lstStyle/>
-          <a:p/>
-          <a:p>
-            <a:pPr lvl="1"/>
-            <a:r>
-              <a:t>Nostalgia for original fans</a:t>
-            </a:r>
-          </a:p>
-          <a:p>
-            <a:pPr lvl="1"/>
-            <a:r>
-              <a:t>Simple yet deep gameplay</a:t>
-            </a:r>
-          </a:p>
-          <a:p>
-            <a:pPr lvl="1"/>
-            <a:r>
-              <a:t>Constant innovation</a:t>
-            </a:r>
-          </a:p>
-          <a:p>
-            <a:pPr lvl="1"/>
-            <a:r>
-              <a:t>Strong community</a:t>
-            </a:r>
-          </a:p>
-          <a:p>
-            <a:pPr lvl="1"/>
-            <a:r>
-              <a:t>Timeless appeal</a:t>
-            </a:r>
-          </a:p>
-        </p:txBody>
-      </p:sp>
-    </p:spTree>
-  </p:cSld>
-  <p:clrMapOvr>
-    <a:masterClrMapping/>
-  </p:clrMapOvr>
-</p:sld>
-</file>
-
-<file path=ppt/slides/slide13.xml><?xml version="1.0" encoding="utf-8"?>
-<p:sld xmlns:a="http://schemas.openxmlformats.org/drawingml/2006/main" xmlns:p="http://schemas.openxmlformats.org/presentationml/2006/main" xmlns:r="http://schemas.openxmlformats.org/officeDocument/2006/relationships">
-  <p:cSld>
-    <p:spTree>
-      <p:nvGrpSpPr>
-        <p:cNvPr id="1" name=""/>
-        <p:cNvGrpSpPr/>
-        <p:nvPr/>
-      </p:nvGrpSpPr>
-      <p:grpSpPr/>
-      <p:sp>
-        <p:nvSpPr>
-          <p:cNvPr id="2" name="Title 1"/>
-          <p:cNvSpPr>
-            <a:spLocks noGrp="1"/>
-          </p:cNvSpPr>
-          <p:nvPr>
-            <p:ph type="title"/>
-          </p:nvPr>
-        </p:nvSpPr>
-        <p:spPr/>
-        <p:txBody>
-          <a:bodyPr/>
-          <a:lstStyle/>
-          <a:p>
-            <a:r>
-              <a:t>Thank You!</a:t>
+            <a:r>
+              <a:t>A legendary superhero team that has captured the hearts of millions worldwide, both in comics and on the silver screen.</a:t>
             </a:r>
           </a:p>
         </p:txBody>
@@ -3485,7 +3173,7 @@
           <a:lstStyle/>
           <a:p>
             <a:r>
-              <a:t>What is Pokémon?</a:t>
+              <a:t>Origins in the Comics</a:t>
             </a:r>
           </a:p>
         </p:txBody>
@@ -3508,31 +3196,31 @@
           <a:p>
             <a:pPr lvl="1"/>
             <a:r>
-              <a:t>Media franchise created by Satoshi Tajiri in 1995</a:t>
-            </a:r>
-          </a:p>
-          <a:p>
-            <a:pPr lvl="1"/>
-            <a:r>
-              <a:t>Short for 'Pocket Monsters' in Japanese</a:t>
-            </a:r>
-          </a:p>
-          <a:p>
-            <a:pPr lvl="1"/>
-            <a:r>
-              <a:t>Features fictional creatures called Pokémon</a:t>
-            </a:r>
-          </a:p>
-          <a:p>
-            <a:pPr lvl="1"/>
-            <a:r>
-              <a:t>Trainers catch and battle Pokémon</a:t>
-            </a:r>
-          </a:p>
-          <a:p>
-            <a:pPr lvl="1"/>
-            <a:r>
-              <a:t>Spanning games, TV shows, movies, cards, and more</a:t>
+              <a:t>First appeared in The Avengers #1 in September 1963</a:t>
+            </a:r>
+          </a:p>
+          <a:p>
+            <a:pPr lvl="1"/>
+            <a:r>
+              <a:t>Created by writer Stan Lee and artist Jack Kirby</a:t>
+            </a:r>
+          </a:p>
+          <a:p>
+            <a:pPr lvl="1"/>
+            <a:r>
+              <a:t>Original team included Iron Man, Thor, Hulk, Ant-Man, and Wasp</a:t>
+            </a:r>
+          </a:p>
+          <a:p>
+            <a:pPr lvl="1"/>
+            <a:r>
+              <a:t>Formed to fight villains too powerful for individual heroes</a:t>
+            </a:r>
+          </a:p>
+          <a:p>
+            <a:pPr lvl="1"/>
+            <a:r>
+              <a:t>Nick Fury later brought the team together as S.H.I.E.L.D. director</a:t>
             </a:r>
           </a:p>
         </p:txBody>
@@ -3571,7 +3259,7 @@
           <a:lstStyle/>
           <a:p>
             <a:r>
-              <a:t>The Beginning: 1996-1998</a:t>
+              <a:t>The Marvel Cinematic Universe</a:t>
             </a:r>
           </a:p>
         </p:txBody>
@@ -3594,31 +3282,31 @@
           <a:p>
             <a:pPr lvl="1"/>
             <a:r>
-              <a:t>Pokémon Red and Green released in Japan (1996)</a:t>
-            </a:r>
-          </a:p>
-          <a:p>
-            <a:pPr lvl="1"/>
-            <a:r>
-              <a:t>Pokémon Blue followed with enhanced graphics</a:t>
-            </a:r>
-          </a:p>
-          <a:p>
-            <a:pPr lvl="1"/>
-            <a:r>
-              <a:t>Revolutionary Game Boy RPG concept</a:t>
-            </a:r>
-          </a:p>
-          <a:p>
-            <a:pPr lvl="1"/>
-            <a:r>
-              <a:t>Trading feature between games</a:t>
-            </a:r>
-          </a:p>
-          <a:p>
-            <a:pPr lvl="1"/>
-            <a:r>
-              <a:t>Slogan: 'Gotta Catch 'Em All!'</a:t>
+              <a:t>MCU's The Avengers released in 2012</a:t>
+            </a:r>
+          </a:p>
+          <a:p>
+            <a:pPr lvl="1"/>
+            <a:r>
+              <a:t>Directed by Joss Whedon</a:t>
+            </a:r>
+          </a:p>
+          <a:p>
+            <a:pPr lvl="1"/>
+            <a:r>
+              <a:t>Brought together heroes from individual films</a:t>
+            </a:r>
+          </a:p>
+          <a:p>
+            <a:pPr lvl="1"/>
+            <a:r>
+              <a:t>Became the third highest-grossing film of all time</a:t>
+            </a:r>
+          </a:p>
+          <a:p>
+            <a:pPr lvl="1"/>
+            <a:r>
+              <a:t>Established the MCU as a dominant force in cinema</a:t>
             </a:r>
           </a:p>
         </p:txBody>
@@ -3657,7 +3345,7 @@
           <a:lstStyle/>
           <a:p>
             <a:r>
-              <a:t>Global Expansion</a:t>
+              <a:t>Core Team Members</a:t>
             </a:r>
           </a:p>
         </p:txBody>
@@ -3680,31 +3368,31 @@
           <a:p>
             <a:pPr lvl="1"/>
             <a:r>
-              <a:t>Pokémon Red and Blue hit North America (1998)</a:t>
-            </a:r>
-          </a:p>
-          <a:p>
-            <a:pPr lvl="1"/>
-            <a:r>
-              <a:t>Anime series premiered worldwide</a:t>
-            </a:r>
-          </a:p>
-          <a:p>
-            <a:pPr lvl="1"/>
-            <a:r>
-              <a:t>Trading Card Game launched</a:t>
-            </a:r>
-          </a:p>
-          <a:p>
-            <a:pPr lvl="1"/>
-            <a:r>
-              <a:t>Pokémon became a cultural phenomenon</a:t>
-            </a:r>
-          </a:p>
-          <a:p>
-            <a:pPr lvl="1"/>
-            <a:r>
-              <a:t>Pikachu became the franchise mascot</a:t>
+              <a:t>Iron Man (Tony Stark) - Genius billionaire with advanced armor</a:t>
+            </a:r>
+          </a:p>
+          <a:p>
+            <a:pPr lvl="1"/>
+            <a:r>
+              <a:t>Captain America (Steve Rogers) - Super-soldier and natural leader</a:t>
+            </a:r>
+          </a:p>
+          <a:p>
+            <a:pPr lvl="1"/>
+            <a:r>
+              <a:t>Thor - God of Thunder from Asgard</a:t>
+            </a:r>
+          </a:p>
+          <a:p>
+            <a:pPr lvl="1"/>
+            <a:r>
+              <a:t>Hulk (Bruce Banner) - Scientist with gamma-powered alter ego</a:t>
+            </a:r>
+          </a:p>
+          <a:p>
+            <a:pPr lvl="1"/>
+            <a:r>
+              <a:t>Black Widow (Natasha Romanoff) - Master spy and assassin</a:t>
             </a:r>
           </a:p>
         </p:txBody>
@@ -3743,7 +3431,7 @@
           <a:lstStyle/>
           <a:p>
             <a:r>
-              <a:t>Core Gameplay Mechanics</a:t>
+              <a:t>Key Villains &amp; Challenges</a:t>
             </a:r>
           </a:p>
         </p:txBody>
@@ -3766,31 +3454,31 @@
           <a:p>
             <a:pPr lvl="1"/>
             <a:r>
-              <a:t>Capture wild Pokémon using Poké Balls</a:t>
-            </a:r>
-          </a:p>
-          <a:p>
-            <a:pPr lvl="1"/>
-            <a:r>
-              <a:t>Train Pokémon to increase levels</a:t>
-            </a:r>
-          </a:p>
-          <a:p>
-            <a:pPr lvl="1"/>
-            <a:r>
-              <a:t>Battle system with type advantages</a:t>
-            </a:r>
-          </a:p>
-          <a:p>
-            <a:pPr lvl="1"/>
-            <a:r>
-              <a:t>Evolution makes Pokémon stronger</a:t>
-            </a:r>
-          </a:p>
-          <a:p>
-            <a:pPr lvl="1"/>
-            <a:r>
-              <a:t>Trade to complete your Pokédex</a:t>
+              <a:t>Loki - Thor's adopted brother and god of mischief</a:t>
+            </a:r>
+          </a:p>
+          <a:p>
+            <a:pPr lvl="1"/>
+            <a:r>
+              <a:t>Thanos - The Mad Titan seeking the Infinity Stones</a:t>
+            </a:r>
+          </a:p>
+          <a:p>
+            <a:pPr lvl="1"/>
+            <a:r>
+              <a:t>Ultron - AI gone rogue created by Tony Stark</a:t>
+            </a:r>
+          </a:p>
+          <a:p>
+            <a:pPr lvl="1"/>
+            <a:r>
+              <a:t>Alien invasions and global threats</a:t>
+            </a:r>
+          </a:p>
+          <a:p>
+            <a:pPr lvl="1"/>
+            <a:r>
+              <a:t>Internal conflicts and personal demons</a:t>
             </a:r>
           </a:p>
         </p:txBody>
@@ -3829,7 +3517,7 @@
           <a:lstStyle/>
           <a:p>
             <a:r>
-              <a:t>Regional Pokémon Variants</a:t>
+              <a:t>Cultural Impact</a:t>
             </a:r>
           </a:p>
         </p:txBody>
@@ -3850,38 +3538,33 @@
           <a:lstStyle/>
           <a:p/>
           <a:p>
-            <a:r>
-              <a:t>Beyond the original 150, Pokémon introduced regional variants that reimagined familiar species</a:t>
-            </a:r>
-          </a:p>
-          <a:p>
-            <a:pPr lvl="1"/>
-            <a:r>
-              <a:t>Alolan forms: Tropical variants from Generation VII</a:t>
-            </a:r>
-          </a:p>
-          <a:p>
-            <a:pPr lvl="1"/>
-            <a:r>
-              <a:t>Galarian forms: British-inspired variants from Generation VIII</a:t>
-            </a:r>
-          </a:p>
-          <a:p>
-            <a:pPr lvl="1"/>
-            <a:r>
-              <a:t>Hisuian forms: Historical variants from Pokémon Legends: Arceus</a:t>
-            </a:r>
-          </a:p>
-          <a:p>
-            <a:pPr lvl="1"/>
-            <a:r>
-              <a:t>Regional variants have different types and abilities</a:t>
-            </a:r>
-          </a:p>
-          <a:p>
-            <a:pPr lvl="1"/>
-            <a:r>
-              <a:t>Shows how Pokémon adapt to different environments</a:t>
+            <a:pPr lvl="1"/>
+            <a:r>
+              <a:t>Revolutionized superhero team-up films</a:t>
+            </a:r>
+          </a:p>
+          <a:p>
+            <a:pPr lvl="1"/>
+            <a:r>
+              <a:t>Created a shared cinematic universe model</a:t>
+            </a:r>
+          </a:p>
+          <a:p>
+            <a:pPr lvl="1"/>
+            <a:r>
+              <a:t>Iconic catchphrases like "Avengers, assemble!"</a:t>
+            </a:r>
+          </a:p>
+          <a:p>
+            <a:pPr lvl="1"/>
+            <a:r>
+              <a:t>Inspired countless merchandise and spin-offs</a:t>
+            </a:r>
+          </a:p>
+          <a:p>
+            <a:pPr lvl="1"/>
+            <a:r>
+              <a:t>Brought comic book culture mainstream</a:t>
             </a:r>
           </a:p>
         </p:txBody>
@@ -3920,7 +3603,7 @@
           <a:lstStyle/>
           <a:p>
             <a:r>
-              <a:t>Evolution Over Generations</a:t>
+              <a:t>Box Office Success</a:t>
             </a:r>
           </a:p>
         </p:txBody>
@@ -3943,31 +3626,31 @@
           <a:p>
             <a:pPr lvl="1"/>
             <a:r>
-              <a:t>Generation II: Johto region (1999)</a:t>
-            </a:r>
-          </a:p>
-          <a:p>
-            <a:pPr lvl="1"/>
-            <a:r>
-              <a:t>Generation III: Hoenn region (2002)</a:t>
-            </a:r>
-          </a:p>
-          <a:p>
-            <a:pPr lvl="1"/>
-            <a:r>
-              <a:t>Generation IV: Sinnoh region (2006)</a:t>
-            </a:r>
-          </a:p>
-          <a:p>
-            <a:pPr lvl="1"/>
-            <a:r>
-              <a:t>Generation VIII: Galar region (2019)</a:t>
-            </a:r>
-          </a:p>
-          <a:p>
-            <a:pPr lvl="1"/>
-            <a:r>
-              <a:t>Over 900 Pokémon species today</a:t>
+              <a:t>Avengers: Endgame became highest-grossing film ever</a:t>
+            </a:r>
+          </a:p>
+          <a:p>
+            <a:pPr lvl="1"/>
+            <a:r>
+              <a:t>Combined MCU films earned over $22 billion</a:t>
+            </a:r>
+          </a:p>
+          <a:p>
+            <a:pPr lvl="1"/>
+            <a:r>
+              <a:t>Avengers films consistently broke records</a:t>
+            </a:r>
+          </a:p>
+          <a:p>
+            <a:pPr lvl="1"/>
+            <a:r>
+              <a:t>Global phenomenon across all demographics</a:t>
+            </a:r>
+          </a:p>
+          <a:p>
+            <a:pPr lvl="1"/>
+            <a:r>
+              <a:t>Set new standards for blockbuster filmmaking</a:t>
             </a:r>
           </a:p>
         </p:txBody>
@@ -4006,7 +3689,7 @@
           <a:lstStyle/>
           <a:p>
             <a:r>
-              <a:t>Battle System Explained</a:t>
+              <a:t>The Avengers Legacy</a:t>
             </a:r>
           </a:p>
         </p:txBody>
@@ -4027,33 +3710,8 @@
           <a:lstStyle/>
           <a:p/>
           <a:p>
-            <a:pPr lvl="1"/>
-            <a:r>
-              <a:t>Turn-based combat system</a:t>
-            </a:r>
-          </a:p>
-          <a:p>
-            <a:pPr lvl="1"/>
-            <a:r>
-              <a:t>18 different Pokémon types</a:t>
-            </a:r>
-          </a:p>
-          <a:p>
-            <a:pPr lvl="1"/>
-            <a:r>
-              <a:t>Rock-Paper-Scissors mechanics</a:t>
-            </a:r>
-          </a:p>
-          <a:p>
-            <a:pPr lvl="1"/>
-            <a:r>
-              <a:t>Status effects and special abilities</a:t>
-            </a:r>
-          </a:p>
-          <a:p>
-            <a:pPr lvl="1"/>
-            <a:r>
-              <a:t>Competitive battling scene</a:t>
+            <a:r>
+              <a:t>The Avengers have redefined modern entertainment, proving that superhero stories can be both commercially successful and critically acclaimed.</a:t>
             </a:r>
           </a:p>
         </p:txBody>
@@ -4092,7 +3750,7 @@
           <a:lstStyle/>
           <a:p>
             <a:r>
-              <a:t>Cultural Impact</a:t>
+              <a:t>Themes That Resonate</a:t>
             </a:r>
           </a:p>
         </p:txBody>
@@ -4113,33 +3771,38 @@
           <a:lstStyle/>
           <a:p/>
           <a:p>
-            <a:pPr lvl="1"/>
-            <a:r>
-              <a:t>Pokémon GO mobile phenomenon (2016)</a:t>
-            </a:r>
-          </a:p>
-          <a:p>
-            <a:pPr lvl="1"/>
-            <a:r>
-              <a:t>Detective Pikachu movie success</a:t>
-            </a:r>
-          </a:p>
-          <a:p>
-            <a:pPr lvl="1"/>
-            <a:r>
-              <a:t>Merchandise worth billions</a:t>
-            </a:r>
-          </a:p>
-          <a:p>
-            <a:pPr lvl="1"/>
-            <a:r>
-              <a:t>Theme parks and attractions</a:t>
-            </a:r>
-          </a:p>
-          <a:p>
-            <a:pPr lvl="1"/>
-            <a:r>
-              <a:t>Global community of fans</a:t>
+            <a:r>
+              <a:t>The Avengers explore universal themes that connect with audiences worldwide.</a:t>
+            </a:r>
+          </a:p>
+          <a:p>
+            <a:pPr lvl="1"/>
+            <a:r>
+              <a:t>Heroism in the face of adversity</a:t>
+            </a:r>
+          </a:p>
+          <a:p>
+            <a:pPr lvl="1"/>
+            <a:r>
+              <a:t>Sacrifice for the greater good</a:t>
+            </a:r>
+          </a:p>
+          <a:p>
+            <a:pPr lvl="1"/>
+            <a:r>
+              <a:t>Unity against overwhelming odds</a:t>
+            </a:r>
+          </a:p>
+          <a:p>
+            <a:pPr lvl="1"/>
+            <a:r>
+              <a:t>Power of teamwork and friendship</a:t>
+            </a:r>
+          </a:p>
+          <a:p>
+            <a:pPr lvl="1"/>
+            <a:r>
+              <a:t>Redemption and second chances</a:t>
             </a:r>
           </a:p>
         </p:txBody>

</xml_diff>